<commit_message>
Update slides with Optuna threshold tuning
Slide 7 (triage policy): add bullet noting thresholds are automatically
calibrated via Bayesian optimisation (Optuna TPE, 300 trials, GPU-batched).
Slide 14 (future work): replace 'broader threshold stability analysis'
with 'threshold stability across distribution shifts' to reflect that
automated calibration is already implemented.
</commit_message>
<xml_diff>
--- a/SABRE_presentation_updated.pptx
+++ b/SABRE_presentation_updated.pptx
@@ -4252,7 +4252,7 @@
                   <a:srgbClr val="1E293B"/>
                 </a:solidFill>
               </a:rPr>
-              <a:t>Future work: matched multimodal datasets, richer behavioural models, broader threshold stability analysis.</a:t>
+              <a:t>Future work: matched multimodal datasets, richer behavioural models, threshold stability across distribution shifts.</a:t>
             </a:r>
             <a:endParaRPr lang="en-US" sz="1700" dirty="0"/>
           </a:p>
@@ -8709,6 +8709,21 @@
                 </a:solidFill>
               </a:rPr>
               <a:t>Main deployment goal: conservative routing of ambiguous cases.</a:t>
+            </a:r>
+            <a:endParaRPr lang="en-US" sz="1600" dirty="0"/>
+          </a:p>
+          <a:p>
+            <a:pPr marL="177800" indent="-177800">
+              <a:buSzPct val="100000"/>
+              <a:buChar char="•"/>
+            </a:pPr>
+            <a:r>
+              <a:rPr lang="en-US" sz="1600" dirty="0">
+                <a:solidFill>
+                  <a:srgbClr val="1E293B"/>
+                </a:solidFill>
+              </a:rPr>
+              <a:t>Thresholds are automatically calibrated via Bayesian optimisation (Optuna TPE, 300 trials, GPU-batched inference).</a:t>
             </a:r>
             <a:endParaRPr lang="en-US" sz="1600" dirty="0"/>
           </a:p>

</xml_diff>

<commit_message>
Remove tracked __pycache__ files and sync presentation
Untrack all .pyc files previously committed before .gitignore was added;
they are now correctly ignored. Also includes the presentation update
from the Optuna slides session.
</commit_message>
<xml_diff>
--- a/SABRE_presentation_updated.pptx
+++ b/SABRE_presentation_updated.pptx
@@ -4934,7 +4934,7 @@
         </p:nvSpPr>
         <p:spPr>
           <a:xfrm>
-            <a:off x="8549640" y="1261872"/>
+            <a:off x="8549640" y="1131238"/>
             <a:ext cx="2103120" cy="822960"/>
           </a:xfrm>
           <a:prstGeom prst="roundRect">
@@ -4975,7 +4975,7 @@
         </p:nvSpPr>
         <p:spPr>
           <a:xfrm>
-            <a:off x="8641080" y="1426464"/>
+            <a:off x="8641080" y="1314492"/>
             <a:ext cx="1920240" cy="411480"/>
           </a:xfrm>
           <a:prstGeom prst="rect">
@@ -5025,7 +5025,7 @@
         </p:nvSpPr>
         <p:spPr>
           <a:xfrm>
-            <a:off x="8549640" y="2377440"/>
+            <a:off x="8549640" y="2162839"/>
             <a:ext cx="2103120" cy="822960"/>
           </a:xfrm>
           <a:prstGeom prst="roundRect">
@@ -5066,7 +5066,7 @@
         </p:nvSpPr>
         <p:spPr>
           <a:xfrm>
-            <a:off x="8641080" y="2542032"/>
+            <a:off x="8641080" y="2374080"/>
             <a:ext cx="1920240" cy="411480"/>
           </a:xfrm>
           <a:prstGeom prst="rect">
@@ -5237,13 +5237,13 @@
       </p:sp>
       <p:sp>
         <p:nvSpPr>
-          <p:cNvPr id="14" name="Shape 12"/>
-          <p:cNvSpPr/>
-          <p:nvPr/>
-        </p:nvSpPr>
-        <p:spPr>
-          <a:xfrm>
-            <a:off x="8549640" y="3108960"/>
+          <p:cNvPr id="7" name="Shape 12"/>
+          <p:cNvSpPr/>
+          <p:nvPr/>
+        </p:nvSpPr>
+        <p:spPr>
+          <a:xfrm>
+            <a:off x="8549640" y="3108955"/>
             <a:ext cx="2103120" cy="822960"/>
           </a:xfrm>
           <a:prstGeom prst="roundRect">
@@ -5278,7 +5278,7 @@
       </p:sp>
       <p:sp>
         <p:nvSpPr>
-          <p:cNvPr id="15" name="Text 13"/>
+          <p:cNvPr id="9" name="Text 13"/>
           <p:cNvSpPr/>
           <p:nvPr/>
         </p:nvSpPr>
@@ -7258,10 +7258,10 @@
       </p:sp>
       <p:pic>
         <p:nvPicPr>
-          <p:cNvPr id="5" name="Picture 4">
+          <p:cNvPr id="4" name="Picture 3">
             <a:extLst>
               <a:ext uri="{FF2B5EF4-FFF2-40B4-BE49-F238E27FC236}">
-                <a16:creationId xmlns:a16="http://schemas.microsoft.com/office/drawing/2014/main" id="{D0BFA837-D314-66EF-6EBA-2E1801755548}"/>
+                <a16:creationId xmlns:a16="http://schemas.microsoft.com/office/drawing/2014/main" id="{D691ABF6-606B-5E9D-AA8D-362836A704F7}"/>
               </a:ext>
             </a:extLst>
           </p:cNvPr>
@@ -7278,8 +7278,8 @@
         </p:blipFill>
         <p:spPr>
           <a:xfrm>
-            <a:off x="244265" y="1539551"/>
-            <a:ext cx="11790162" cy="3806890"/>
+            <a:off x="212343" y="1026367"/>
+            <a:ext cx="11656196" cy="4759890"/>
           </a:xfrm>
           <a:prstGeom prst="rect">
             <a:avLst/>
@@ -7964,8 +7964,8 @@
         </p:nvSpPr>
         <p:spPr>
           <a:xfrm>
-            <a:off x="1051560" y="4892040"/>
-            <a:ext cx="1280160" cy="804672"/>
+            <a:off x="535578" y="4892040"/>
+            <a:ext cx="1796142" cy="804672"/>
           </a:xfrm>
           <a:prstGeom prst="roundRect">
             <a:avLst>
@@ -8005,8 +8005,8 @@
         </p:nvSpPr>
         <p:spPr>
           <a:xfrm>
-            <a:off x="1143000" y="5029200"/>
-            <a:ext cx="1097280" cy="320040"/>
+            <a:off x="550512" y="4926559"/>
+            <a:ext cx="1820402" cy="320040"/>
           </a:xfrm>
           <a:prstGeom prst="rect">
             <a:avLst/>
@@ -8481,7 +8481,7 @@
         <p:spPr>
           <a:xfrm>
             <a:off x="722377" y="1234440"/>
-            <a:ext cx="5029200" cy="4526280"/>
+            <a:ext cx="5029200" cy="5138368"/>
           </a:xfrm>
           <a:prstGeom prst="roundRect">
             <a:avLst>
@@ -8656,7 +8656,7 @@
         <p:spPr>
           <a:xfrm>
             <a:off x="914400" y="3840480"/>
-            <a:ext cx="4617718" cy="1554480"/>
+            <a:ext cx="4617718" cy="2280402"/>
           </a:xfrm>
           <a:prstGeom prst="rect">
             <a:avLst/>
@@ -10123,7 +10123,7 @@
       </p:sp>
       <p:sp>
         <p:nvSpPr>
-          <p:cNvPr id="21" name="Text 17"/>
+          <p:cNvPr id="9" name="Text 17"/>
           <p:cNvSpPr/>
           <p:nvPr/>
         </p:nvSpPr>
@@ -10159,7 +10159,7 @@
       </p:sp>
       <p:sp>
         <p:nvSpPr>
-          <p:cNvPr id="22" name="Text 18"/>
+          <p:cNvPr id="23" name="Text 18"/>
           <p:cNvSpPr/>
           <p:nvPr/>
         </p:nvSpPr>
@@ -10195,7 +10195,7 @@
       </p:sp>
       <p:sp>
         <p:nvSpPr>
-          <p:cNvPr id="21" name="Text 17"/>
+          <p:cNvPr id="24" name="Text 17"/>
           <p:cNvSpPr/>
           <p:nvPr/>
         </p:nvSpPr>
@@ -10231,7 +10231,7 @@
       </p:sp>
       <p:sp>
         <p:nvSpPr>
-          <p:cNvPr id="22" name="Text 18"/>
+          <p:cNvPr id="25" name="Text 18"/>
           <p:cNvSpPr/>
           <p:nvPr/>
         </p:nvSpPr>

</xml_diff>

<commit_message>
Fix dataset references on slides 3 and 14
Slide 3 (agenda): update data & evaluation item to name all three
independent datasets (RDset, RanSMAP, RansKnow).
Slide 14 (limitations): update first bullet to reflect all three
datasets are independent with no matched multimodal views.
</commit_message>
<xml_diff>
--- a/SABRE_presentation_updated.pptx
+++ b/SABRE_presentation_updated.pptx
@@ -4207,7 +4207,7 @@
                   <a:srgbClr val="1E293B"/>
                 </a:solidFill>
               </a:rPr>
-              <a:t>RDset and RanSMAP are complementary, not matched multimodal views.</a:t>
+              <a:t>RDset, RanSMAP, and RansKnow are independent datasets — no matched multimodal views across all three modalities.</a:t>
             </a:r>
             <a:endParaRPr lang="en-US" sz="1700" dirty="0"/>
           </a:p>
@@ -5931,7 +5931,7 @@
                   <a:srgbClr val="1E293B"/>
                 </a:solidFill>
               </a:rPr>
-              <a:t>RDset and RanSMAP as complementary semantic and behavioural settings</a:t>
+              <a:t>RDset, RanSMAP, and RansKnow as independent semantic, behavioural, and knowledge settings</a:t>
             </a:r>
             <a:endParaRPr lang="en-US" sz="1400" dirty="0"/>
           </a:p>

</xml_diff>